<commit_message>
Fixed inconsistency in architecture powerpoint
</commit_message>
<xml_diff>
--- a/Rattlesnake Architecture.pptx
+++ b/Rattlesnake Architecture.pptx
@@ -227,7 +227,7 @@
           <a:p>
             <a:fld id="{5E1FC465-60AB-408F-8107-10891B2ACC4C}" type="datetimeFigureOut">
               <a:rPr lang="en-US" smtClean="0"/>
-              <a:t>2/5/2026</a:t>
+              <a:t>2/6/2026</a:t>
             </a:fld>
             <a:endParaRPr lang="en-US"/>
           </a:p>
@@ -1465,7 +1465,7 @@
           <a:p>
             <a:fld id="{D4E51A13-A9DD-45EE-BBC0-E2EC78A76ABF}" type="datetimeFigureOut">
               <a:rPr lang="en-US" smtClean="0"/>
-              <a:t>2/5/2026</a:t>
+              <a:t>2/6/2026</a:t>
             </a:fld>
             <a:endParaRPr lang="en-US"/>
           </a:p>
@@ -1635,7 +1635,7 @@
           <a:p>
             <a:fld id="{D4E51A13-A9DD-45EE-BBC0-E2EC78A76ABF}" type="datetimeFigureOut">
               <a:rPr lang="en-US" smtClean="0"/>
-              <a:t>2/5/2026</a:t>
+              <a:t>2/6/2026</a:t>
             </a:fld>
             <a:endParaRPr lang="en-US"/>
           </a:p>
@@ -1815,7 +1815,7 @@
           <a:p>
             <a:fld id="{D4E51A13-A9DD-45EE-BBC0-E2EC78A76ABF}" type="datetimeFigureOut">
               <a:rPr lang="en-US" smtClean="0"/>
-              <a:t>2/5/2026</a:t>
+              <a:t>2/6/2026</a:t>
             </a:fld>
             <a:endParaRPr lang="en-US"/>
           </a:p>
@@ -1985,7 +1985,7 @@
           <a:p>
             <a:fld id="{D4E51A13-A9DD-45EE-BBC0-E2EC78A76ABF}" type="datetimeFigureOut">
               <a:rPr lang="en-US" smtClean="0"/>
-              <a:t>2/5/2026</a:t>
+              <a:t>2/6/2026</a:t>
             </a:fld>
             <a:endParaRPr lang="en-US"/>
           </a:p>
@@ -2231,7 +2231,7 @@
           <a:p>
             <a:fld id="{D4E51A13-A9DD-45EE-BBC0-E2EC78A76ABF}" type="datetimeFigureOut">
               <a:rPr lang="en-US" smtClean="0"/>
-              <a:t>2/5/2026</a:t>
+              <a:t>2/6/2026</a:t>
             </a:fld>
             <a:endParaRPr lang="en-US"/>
           </a:p>
@@ -2463,7 +2463,7 @@
           <a:p>
             <a:fld id="{D4E51A13-A9DD-45EE-BBC0-E2EC78A76ABF}" type="datetimeFigureOut">
               <a:rPr lang="en-US" smtClean="0"/>
-              <a:t>2/5/2026</a:t>
+              <a:t>2/6/2026</a:t>
             </a:fld>
             <a:endParaRPr lang="en-US"/>
           </a:p>
@@ -2830,7 +2830,7 @@
           <a:p>
             <a:fld id="{D4E51A13-A9DD-45EE-BBC0-E2EC78A76ABF}" type="datetimeFigureOut">
               <a:rPr lang="en-US" smtClean="0"/>
-              <a:t>2/5/2026</a:t>
+              <a:t>2/6/2026</a:t>
             </a:fld>
             <a:endParaRPr lang="en-US"/>
           </a:p>
@@ -2948,7 +2948,7 @@
           <a:p>
             <a:fld id="{D4E51A13-A9DD-45EE-BBC0-E2EC78A76ABF}" type="datetimeFigureOut">
               <a:rPr lang="en-US" smtClean="0"/>
-              <a:t>2/5/2026</a:t>
+              <a:t>2/6/2026</a:t>
             </a:fld>
             <a:endParaRPr lang="en-US"/>
           </a:p>
@@ -3043,7 +3043,7 @@
           <a:p>
             <a:fld id="{D4E51A13-A9DD-45EE-BBC0-E2EC78A76ABF}" type="datetimeFigureOut">
               <a:rPr lang="en-US" smtClean="0"/>
-              <a:t>2/5/2026</a:t>
+              <a:t>2/6/2026</a:t>
             </a:fld>
             <a:endParaRPr lang="en-US"/>
           </a:p>
@@ -3320,7 +3320,7 @@
           <a:p>
             <a:fld id="{D4E51A13-A9DD-45EE-BBC0-E2EC78A76ABF}" type="datetimeFigureOut">
               <a:rPr lang="en-US" smtClean="0"/>
-              <a:t>2/5/2026</a:t>
+              <a:t>2/6/2026</a:t>
             </a:fld>
             <a:endParaRPr lang="en-US"/>
           </a:p>
@@ -3577,7 +3577,7 @@
           <a:p>
             <a:fld id="{D4E51A13-A9DD-45EE-BBC0-E2EC78A76ABF}" type="datetimeFigureOut">
               <a:rPr lang="en-US" smtClean="0"/>
-              <a:t>2/5/2026</a:t>
+              <a:t>2/6/2026</a:t>
             </a:fld>
             <a:endParaRPr lang="en-US"/>
           </a:p>
@@ -3790,7 +3790,7 @@
           <a:p>
             <a:fld id="{D4E51A13-A9DD-45EE-BBC0-E2EC78A76ABF}" type="datetimeFigureOut">
               <a:rPr lang="en-US" smtClean="0"/>
-              <a:t>2/5/2026</a:t>
+              <a:t>2/6/2026</a:t>
             </a:fld>
             <a:endParaRPr lang="en-US"/>
           </a:p>
@@ -4958,8 +4958,8 @@
         </p:nvSpPr>
         <p:spPr>
           <a:xfrm>
-            <a:off x="1257300" y="2434167"/>
-            <a:ext cx="15773400" cy="6370528"/>
+            <a:off x="1257300" y="1920815"/>
+            <a:ext cx="15773400" cy="6883880"/>
           </a:xfrm>
         </p:spPr>
         <p:txBody>
@@ -4972,7 +4972,7 @@
               <a:buNone/>
             </a:pPr>
             <a:r>
-              <a:rPr lang="en-US" sz="3000" dirty="0"/>
+              <a:rPr lang="en-US" sz="2800" dirty="0"/>
               <a:t>The profile manager is responsible for validating profile events and firing/stopping the timers.</a:t>
             </a:r>
           </a:p>
@@ -4980,97 +4980,126 @@
             <a:pPr marL="0" indent="0">
               <a:buNone/>
             </a:pPr>
-            <a:endParaRPr lang="en-US" sz="3000" dirty="0"/>
+            <a:endParaRPr lang="en-US" sz="2800" dirty="0"/>
           </a:p>
           <a:p>
             <a:pPr marL="0" indent="0">
               <a:buNone/>
             </a:pPr>
             <a:r>
-              <a:rPr lang="en-US" sz="3000" dirty="0" err="1"/>
+              <a:rPr lang="en-US" sz="2800" dirty="0" err="1"/>
               <a:t>Start_profile</a:t>
             </a:r>
             <a:r>
-              <a:rPr lang="en-US" sz="3000" dirty="0"/>
+              <a:rPr lang="en-US" sz="2800" dirty="0"/>
               <a:t>() requires a list of </a:t>
             </a:r>
             <a:r>
-              <a:rPr lang="en-US" sz="3000" dirty="0" err="1"/>
+              <a:rPr lang="en-US" sz="2800" dirty="0" err="1"/>
               <a:t>environment_instructions</a:t>
             </a:r>
             <a:r>
-              <a:rPr lang="en-US" sz="3000" dirty="0"/>
+              <a:rPr lang="en-US" sz="2800" dirty="0"/>
               <a:t> and </a:t>
             </a:r>
             <a:r>
-              <a:rPr lang="en-US" sz="3000" dirty="0" err="1"/>
+              <a:rPr lang="en-US" sz="2800" dirty="0" err="1"/>
               <a:t>profile_events</a:t>
             </a:r>
-            <a:endParaRPr lang="en-US" sz="3000" dirty="0"/>
-          </a:p>
-          <a:p>
-            <a:r>
-              <a:rPr lang="en-US" sz="3000" dirty="0"/>
+            <a:endParaRPr lang="en-US" sz="2800" dirty="0"/>
+          </a:p>
+          <a:p>
+            <a:r>
+              <a:rPr lang="en-US" sz="2800" dirty="0"/>
               <a:t>Environment instructions are optional. If they don’t exist, the first </a:t>
             </a:r>
             <a:r>
-              <a:rPr lang="en-US" sz="3000" dirty="0" err="1"/>
+              <a:rPr lang="en-US" sz="2800" dirty="0" err="1"/>
               <a:t>start_environment</a:t>
             </a:r>
             <a:r>
-              <a:rPr lang="en-US" sz="3000" dirty="0"/>
+              <a:rPr lang="en-US" sz="2800" dirty="0"/>
               <a:t> command will be fired with None as the datatype</a:t>
             </a:r>
           </a:p>
           <a:p>
             <a:r>
-              <a:rPr lang="en-US" sz="3000" dirty="0"/>
+              <a:rPr lang="en-US" sz="2800" dirty="0"/>
               <a:t>If you use a profile event that requires an instruction, it is enforced that you have an instruction for that environment</a:t>
             </a:r>
           </a:p>
           <a:p>
             <a:pPr lvl="1"/>
             <a:r>
-              <a:rPr lang="en-US" sz="3000" dirty="0"/>
+              <a:rPr lang="en-US" sz="2800" dirty="0"/>
               <a:t>Ex: </a:t>
             </a:r>
             <a:r>
-              <a:rPr lang="en-US" sz="3000" dirty="0" err="1"/>
+              <a:rPr lang="en-US" sz="2800" dirty="0" err="1"/>
               <a:t>set_test_level</a:t>
             </a:r>
             <a:r>
-              <a:rPr lang="en-US" sz="3000" dirty="0"/>
+              <a:rPr lang="en-US" sz="2800" dirty="0"/>
               <a:t> requires an object to set a </a:t>
             </a:r>
             <a:r>
-              <a:rPr lang="en-US" sz="3000" dirty="0" err="1"/>
+              <a:rPr lang="en-US" sz="2800" dirty="0" err="1"/>
               <a:t>test_level</a:t>
             </a:r>
             <a:r>
-              <a:rPr lang="en-US" sz="3000" dirty="0"/>
+              <a:rPr lang="en-US" sz="2800" dirty="0"/>
               <a:t> to.</a:t>
             </a:r>
           </a:p>
           <a:p>
             <a:r>
-              <a:rPr lang="en-US" sz="3000" dirty="0"/>
+              <a:rPr lang="en-US" sz="2800" dirty="0"/>
               <a:t>Environment instructions require </a:t>
             </a:r>
             <a:r>
-              <a:rPr lang="en-US" sz="3000" dirty="0" err="1"/>
+              <a:rPr lang="en-US" sz="2800" dirty="0" err="1"/>
               <a:t>environment_name</a:t>
             </a:r>
             <a:r>
-              <a:rPr lang="en-US" sz="3000" dirty="0"/>
+              <a:rPr lang="en-US" sz="2800" dirty="0"/>
               <a:t> (frontend) and </a:t>
             </a:r>
             <a:r>
-              <a:rPr lang="en-US" sz="3000" dirty="0" err="1"/>
+              <a:rPr lang="en-US" sz="2800" dirty="0" err="1"/>
               <a:t>environment_type</a:t>
             </a:r>
             <a:r>
-              <a:rPr lang="en-US" sz="3000" dirty="0"/>
+              <a:rPr lang="en-US" sz="2800" dirty="0"/>
               <a:t> for validation purposes</a:t>
+            </a:r>
+          </a:p>
+          <a:p>
+            <a:pPr marL="0" indent="0">
+              <a:buNone/>
+            </a:pPr>
+            <a:endParaRPr lang="en-US" sz="2800" dirty="0"/>
+          </a:p>
+          <a:p>
+            <a:pPr marL="0" indent="0">
+              <a:buNone/>
+            </a:pPr>
+            <a:r>
+              <a:rPr lang="en-US" sz="2800" dirty="0"/>
+              <a:t>Manager is also the new home for profile event functions. (</a:t>
+            </a:r>
+            <a:r>
+              <a:rPr lang="en-US" sz="2800" dirty="0" err="1"/>
+              <a:t>Time.Set_Test_Level</a:t>
+            </a:r>
+            <a:r>
+              <a:rPr lang="en-US" sz="2800" dirty="0"/>
+              <a:t>)</a:t>
+            </a:r>
+          </a:p>
+          <a:p>
+            <a:r>
+              <a:rPr lang="en-US" sz="2800" dirty="0"/>
+              <a:t>If Environment has a unique function, must be added to controller functions and mapped accordingly</a:t>
             </a:r>
           </a:p>
         </p:txBody>
@@ -9663,8 +9692,13 @@
             </a:pPr>
             <a:r>
               <a:rPr lang="en-US" sz="3000" dirty="0"/>
-              <a:t>I changed around the file structure a decent bit</a:t>
-            </a:r>
+              <a:t>I changed around the file structure a decent bit to avoid </a:t>
+            </a:r>
+            <a:r>
+              <a:rPr lang="en-US" sz="3000"/>
+              <a:t>circular imports</a:t>
+            </a:r>
+            <a:endParaRPr lang="en-US" sz="3000" dirty="0"/>
           </a:p>
           <a:p>
             <a:r>
@@ -14197,27 +14231,6 @@
             <a:r>
               <a:rPr lang="en-US" sz="3000" dirty="0"/>
               <a:t>, etc.</a:t>
-            </a:r>
-          </a:p>
-          <a:p>
-            <a:r>
-              <a:rPr lang="en-US" sz="3000" dirty="0"/>
-              <a:t>Controller is also the new home for profile event functions. (</a:t>
-            </a:r>
-            <a:r>
-              <a:rPr lang="en-US" sz="3000" dirty="0" err="1"/>
-              <a:t>Time.Set_Test_Level</a:t>
-            </a:r>
-            <a:r>
-              <a:rPr lang="en-US" sz="3000" dirty="0"/>
-              <a:t>)</a:t>
-            </a:r>
-          </a:p>
-          <a:p>
-            <a:pPr lvl="1"/>
-            <a:r>
-              <a:rPr lang="en-US" sz="3000" dirty="0"/>
-              <a:t>If Environment has a unique function, must be added to controller functions and mapped accordingly</a:t>
             </a:r>
           </a:p>
         </p:txBody>

</xml_diff>